<commit_message>
Se suben la diapositiva final y el informe del proyecto
</commit_message>
<xml_diff>
--- a/Documentacion/Afinador_Violin_IA.pptx
+++ b/Documentacion/Afinador_Violin_IA.pptx
@@ -147,7 +147,7 @@
     </p:spTree>
     <p:extLst>
       <p:ext uri="{BB962C8B-B14F-4D97-AF65-F5344CB8AC3E}">
-        <p14:creationId xmlns:p14="http://schemas.microsoft.com/office/powerpoint/2010/main" val="751248010"/>
+        <p14:creationId xmlns:p14="http://schemas.microsoft.com/office/powerpoint/2010/main" val="3692201793"/>
       </p:ext>
     </p:extLst>
   </p:cSld>
@@ -1764,7 +1764,7 @@
               <a:buNone/>
             </a:pPr>
             <a:r>
-              <a:rPr lang="en-US" sz="1300" dirty="0" err="1">
+              <a:rPr lang="en-US" sz="1300" dirty="0">
                 <a:solidFill>
                   <a:srgbClr val="F5EDE0"/>
                 </a:solidFill>
@@ -1772,18 +1772,7 @@
                 <a:ea typeface="Calibri" pitchFamily="34" charset="-122"/>
                 <a:cs typeface="Calibri" pitchFamily="34" charset="-120"/>
               </a:rPr>
-              <a:t>Belén</a:t>
-            </a:r>
-            <a:r>
-              <a:rPr lang="en-US" sz="1300" dirty="0">
-                <a:solidFill>
-                  <a:srgbClr val="F5EDE0"/>
-                </a:solidFill>
-                <a:latin typeface="Calibri" pitchFamily="34" charset="0"/>
-                <a:ea typeface="Calibri" pitchFamily="34" charset="-122"/>
-                <a:cs typeface="Calibri" pitchFamily="34" charset="-120"/>
-              </a:rPr>
-              <a:t> Mejia Medina  |  Ingeniería en Inteligencia Artificial</a:t>
+              <a:t>Belen Mejia Medina  |  Ingeniería en Inteligencia Artificial</a:t>
             </a:r>
             <a:endParaRPr lang="en-US" sz="1300" dirty="0"/>
           </a:p>
@@ -1954,7 +1943,23 @@
                   <a:srgbClr val="F5EDE0"/>
                 </a:solidFill>
               </a:rPr>
-              <a:t>Las decisiones técnicas (2 clases, librosa sobre aubio, hilos separados) surgieron de problemas reales encontrados durante el desarrollo, no de la teoría</a:t>
+              <a:t>Las decisiones </a:t>
+            </a:r>
+            <a:r>
+              <a:rPr lang="en-US" sz="1450" dirty="0" err="1">
+                <a:solidFill>
+                  <a:srgbClr val="F5EDE0"/>
+                </a:solidFill>
+              </a:rPr>
+              <a:t>técnicas</a:t>
+            </a:r>
+            <a:r>
+              <a:rPr lang="en-US" sz="1450" dirty="0">
+                <a:solidFill>
+                  <a:srgbClr val="F5EDE0"/>
+                </a:solidFill>
+              </a:rPr>
+              <a:t> (3 clases, librosa sobre aubio, hilos separados) surgieron de problemas reales encontrados durante el desarrollo, no de la teoría</a:t>
             </a:r>
             <a:endParaRPr lang="en-US" sz="1450" dirty="0"/>
           </a:p>
@@ -2925,7 +2930,7 @@
                   <a:srgbClr val="2E1B0E"/>
                 </a:solidFill>
               </a:rPr>
-              <a:t> SOL, RE, LA, MI (196.00 Hz, 293.00 Hz, 440Hz, 659.25 Hz) de un violín en tiempo real</a:t>
+              <a:t> La (440Hz), Sol (196Hz), Re (293.66Hz), Mi (659.25) de un violín en tiempo real</a:t>
             </a:r>
             <a:endParaRPr lang="en-US" sz="1600" dirty="0"/>
           </a:p>
@@ -5471,6 +5476,13 @@
           </a:solidFill>
           <a:ln/>
         </p:spPr>
+        <p:txBody>
+          <a:bodyPr/>
+          <a:lstStyle/>
+          <a:p>
+            <a:endParaRPr/>
+          </a:p>
+        </p:txBody>
       </p:sp>
       <p:sp>
         <p:nvSpPr>
@@ -5499,13 +5511,13 @@
             <a:r>
               <a:rPr lang="en-US" sz="4000" b="1" dirty="0">
                 <a:solidFill>
-                  <a:srgbClr val="5C3A21"/>
+                  <a:srgbClr val="C0392B"/>
                 </a:solidFill>
                 <a:latin typeface="Cambria" pitchFamily="34" charset="0"/>
                 <a:ea typeface="Cambria" pitchFamily="34" charset="-122"/>
                 <a:cs typeface="Cambria" pitchFamily="34" charset="-120"/>
               </a:rPr>
-              <a:t>4</a:t>
+              <a:t>56,1 %</a:t>
             </a:r>
             <a:endParaRPr lang="en-US" sz="4000" dirty="0"/>
           </a:p>
@@ -5544,14 +5556,9 @@
                 <a:ea typeface="Calibri" pitchFamily="34" charset="-122"/>
                 <a:cs typeface="Calibri" pitchFamily="34" charset="-120"/>
               </a:rPr>
-              <a:t>cuerdas soportadas</a:t>
-            </a:r>
-            <a:endParaRPr lang="en-US" sz="1200" dirty="0"/>
-          </a:p>
-          <a:p>
-            <a:pPr marL="0" indent="0" algn="ctr">
-              <a:buNone/>
-            </a:pPr>
+              <a:t>concordancia solo con</a:t>
+            </a:r>
+            <a:br/>
             <a:r>
               <a:rPr lang="en-US" sz="1200" dirty="0">
                 <a:solidFill>
@@ -5561,7 +5568,7 @@
                 <a:ea typeface="Calibri" pitchFamily="34" charset="-122"/>
                 <a:cs typeface="Calibri" pitchFamily="34" charset="-120"/>
               </a:rPr>
-              <a:t>(Sol, Re, La, Mi)</a:t>
+              <a:t>la etiqueta del clasificador</a:t>
             </a:r>
             <a:endParaRPr lang="en-US" sz="1200" dirty="0"/>
           </a:p>
@@ -5588,6 +5595,13 @@
           </a:solidFill>
           <a:ln/>
         </p:spPr>
+        <p:txBody>
+          <a:bodyPr/>
+          <a:lstStyle/>
+          <a:p>
+            <a:endParaRPr/>
+          </a:p>
+        </p:txBody>
       </p:sp>
       <p:sp>
         <p:nvSpPr>
@@ -5622,7 +5636,7 @@
                 <a:ea typeface="Cambria" pitchFamily="34" charset="-122"/>
                 <a:cs typeface="Cambria" pitchFamily="34" charset="-120"/>
               </a:rPr>
-              <a:t>±10</a:t>
+              <a:t>92,1 %</a:t>
             </a:r>
             <a:endParaRPr lang="en-US" sz="4000" dirty="0"/>
           </a:p>
@@ -5661,14 +5675,9 @@
                 <a:ea typeface="Calibri" pitchFamily="34" charset="-122"/>
                 <a:cs typeface="Calibri" pitchFamily="34" charset="-120"/>
               </a:rPr>
-              <a:t>cents de precisión</a:t>
-            </a:r>
-            <a:endParaRPr lang="en-US" sz="1200" dirty="0"/>
-          </a:p>
-          <a:p>
-            <a:pPr marL="0" indent="0" algn="ctr">
-              <a:buNone/>
-            </a:pPr>
+              <a:t>concordancia con corrección</a:t>
+            </a:r>
+            <a:br/>
             <a:r>
               <a:rPr lang="en-US" sz="1200" dirty="0">
                 <a:solidFill>
@@ -5678,7 +5687,7 @@
                 <a:ea typeface="Calibri" pitchFamily="34" charset="-122"/>
                 <a:cs typeface="Calibri" pitchFamily="34" charset="-120"/>
               </a:rPr>
-              <a:t>típica (ej: 437.5 Hz)</a:t>
+              <a:t>por cents (105 de 114 lecturas)</a:t>
             </a:r>
             <a:endParaRPr lang="en-US" sz="1200" dirty="0"/>
           </a:p>
@@ -5705,6 +5714,13 @@
           </a:solidFill>
           <a:ln/>
         </p:spPr>
+        <p:txBody>
+          <a:bodyPr/>
+          <a:lstStyle/>
+          <a:p>
+            <a:endParaRPr/>
+          </a:p>
+        </p:txBody>
       </p:sp>
       <p:sp>
         <p:nvSpPr>
@@ -5733,13 +5749,13 @@
             <a:r>
               <a:rPr lang="en-US" sz="4000" b="1" dirty="0">
                 <a:solidFill>
-                  <a:srgbClr val="B3261E"/>
+                  <a:srgbClr val="5C3A21"/>
                 </a:solidFill>
                 <a:latin typeface="Cambria" pitchFamily="34" charset="0"/>
                 <a:ea typeface="Cambria" pitchFamily="34" charset="-122"/>
                 <a:cs typeface="Cambria" pitchFamily="34" charset="-120"/>
               </a:rPr>
-              <a:t>100%</a:t>
+              <a:t>10 cents</a:t>
             </a:r>
             <a:endParaRPr lang="en-US" sz="4000" dirty="0"/>
           </a:p>
@@ -5778,14 +5794,9 @@
                 <a:ea typeface="Calibri" pitchFamily="34" charset="-122"/>
                 <a:cs typeface="Calibri" pitchFamily="34" charset="-120"/>
               </a:rPr>
-              <a:t>identificación correcta</a:t>
-            </a:r>
-            <a:endParaRPr lang="en-US" sz="1200" dirty="0"/>
-          </a:p>
-          <a:p>
-            <a:pPr marL="0" indent="0" algn="ctr">
-              <a:buNone/>
-            </a:pPr>
+              <a:t>resolución actual de la</a:t>
+            </a:r>
+            <a:br/>
             <a:r>
               <a:rPr lang="en-US" sz="1200" dirty="0">
                 <a:solidFill>
@@ -5795,7 +5806,7 @@
                 <a:ea typeface="Calibri" pitchFamily="34" charset="-122"/>
                 <a:cs typeface="Calibri" pitchFamily="34" charset="-120"/>
               </a:rPr>
-              <a:t>de cuerda (post-corrección)</a:t>
+              <a:t>estimación de frecuencia</a:t>
             </a:r>
             <a:endParaRPr lang="en-US" sz="1200" dirty="0"/>
           </a:p>
@@ -5874,7 +5885,7 @@
                   <a:srgbClr val="2E1B0E"/>
                 </a:solidFill>
               </a:rPr>
-              <a:t>3 clases por matiz de desafinación: confianza inestable (26–65%), clases confundidas entre sí</a:t>
+              <a:t>3 clases por matiz de desafinación: confianza inestable (39–65 %), clases confundidas entre sí</a:t>
             </a:r>
             <a:endParaRPr lang="en-US" sz="1300" dirty="0"/>
           </a:p>
@@ -5934,6 +5945,13 @@
           </a:solidFill>
           <a:ln/>
         </p:spPr>
+        <p:txBody>
+          <a:bodyPr/>
+          <a:lstStyle/>
+          <a:p>
+            <a:endParaRPr/>
+          </a:p>
+        </p:txBody>
       </p:sp>
       <p:sp>
         <p:nvSpPr>
@@ -6890,65 +6908,8 @@
                   <a:srgbClr val="FFFFFF"/>
                 </a:solidFill>
               </a:rPr>
-              <a:t>Extender a las demás notas naturales de la escala (no solo cuerdas al aire) — solo requiere ampliar el diccionario de </a:t>
-            </a:r>
-            <a:r>
-              <a:rPr lang="en-US" sz="1300" dirty="0" err="1">
-                <a:solidFill>
-                  <a:srgbClr val="FFFFFF"/>
-                </a:solidFill>
-              </a:rPr>
-              <a:t>referencias</a:t>
-            </a:r>
-            <a:r>
-              <a:rPr lang="en-US" sz="1300" dirty="0">
-                <a:solidFill>
-                  <a:srgbClr val="FFFFFF"/>
-                </a:solidFill>
-              </a:rPr>
-              <a:t>, sin </a:t>
-            </a:r>
-            <a:r>
-              <a:rPr lang="en-US" sz="1300" dirty="0" err="1">
-                <a:solidFill>
-                  <a:srgbClr val="FFFFFF"/>
-                </a:solidFill>
-              </a:rPr>
-              <a:t>reentrenar</a:t>
-            </a:r>
-            <a:r>
-              <a:rPr lang="en-US" sz="1300" dirty="0">
-                <a:solidFill>
-                  <a:srgbClr val="FFFFFF"/>
-                </a:solidFill>
-              </a:rPr>
-              <a:t> </a:t>
-            </a:r>
-            <a:r>
-              <a:rPr lang="en-US" sz="1300" dirty="0" err="1">
-                <a:solidFill>
-                  <a:srgbClr val="FFFFFF"/>
-                </a:solidFill>
-              </a:rPr>
-              <a:t>el</a:t>
-            </a:r>
-            <a:r>
-              <a:rPr lang="en-US" sz="1300" dirty="0">
-                <a:solidFill>
-                  <a:srgbClr val="FFFFFF"/>
-                </a:solidFill>
-              </a:rPr>
-              <a:t> </a:t>
-            </a:r>
-            <a:r>
-              <a:rPr lang="en-US" sz="1300" dirty="0" err="1">
-                <a:solidFill>
-                  <a:srgbClr val="FFFFFF"/>
-                </a:solidFill>
-              </a:rPr>
-              <a:t>clasificador</a:t>
-            </a:r>
-            <a:endParaRPr lang="en-US" sz="1300" dirty="0"/>
+              <a:t>Extender a las demás notas naturales de la escala (no solo cuerdas al aire) </a:t>
+            </a:r>
           </a:p>
           <a:p>
             <a:pPr marL="342900" indent="-342900">
@@ -6959,12 +6920,20 @@
               <a:buChar char="•"/>
             </a:pPr>
             <a:r>
+              <a:rPr lang="en-US" sz="1300" dirty="0" err="1">
+                <a:solidFill>
+                  <a:srgbClr val="FFFFFF"/>
+                </a:solidFill>
+              </a:rPr>
+              <a:t>Reducir</a:t>
+            </a:r>
+            <a:r>
               <a:rPr lang="en-US" sz="1300" dirty="0">
                 <a:solidFill>
                   <a:srgbClr val="FFFFFF"/>
                 </a:solidFill>
               </a:rPr>
-              <a:t>Reducir la latencia con ventanas de análisis más pequeñas</a:t>
+              <a:t> la latencia con ventanas de análisis más pequeñas</a:t>
             </a:r>
             <a:endParaRPr lang="en-US" sz="1300" dirty="0"/>
           </a:p>

</xml_diff>